<commit_message>
feat: round 23 - PPT Master v6.4.0 deck (12 pages, native DrawingML) + SVG sources + build record + manifest now declares 7 artifacts
Co-authored-by: arena-agent <297053741+arena-agent@users.noreply.github.com>
</commit_message>
<xml_diff>
--- a/deliverable/DELIVERY_01a0aa00_v2.8.1.pptx
+++ b/deliverable/DELIVERY_01a0aa00_v2.8.1.pptx
@@ -3236,6 +3236,14 @@
               <a:defRPr sz="1300"/>
             </a:pPr>
             <a:r>
+              <a:t>deliverable/DECK_01a0aa00_v2.8.1.pptx (pptx, 46582 B, sha256 0c2ff1af1f79...)</a:t>
+            </a:r>
+          </a:p>
+          <a:p>
+            <a:pPr>
+              <a:defRPr sz="1300"/>
+            </a:pPr>
+            <a:r>
               <a:t>生成器 code/make_bridge_report.py（先过 3a-3g 镜像自检）</a:t>
             </a:r>
           </a:p>
@@ -3299,7 +3307,7 @@
               <a:defRPr sz="1300"/>
             </a:pPr>
             <a:r>
-              <a:t>round 18 on LAPTOP-R77M5D6M - passed</a:t>
+              <a:t>round 20 on LAPTOP-R77M5D6M - passed</a:t>
             </a:r>
           </a:p>
           <a:p>
@@ -3307,7 +3315,7 @@
               <a:defRPr sz="1300"/>
             </a:pPr>
             <a:r>
-              <a:t>round 20 on LAPTOP-R77M5D6M - passed</a:t>
+              <a:t>round 21 on LAPTOP-R77M5D6M - passed</a:t>
             </a:r>
           </a:p>
           <a:p>
@@ -3315,7 +3323,7 @@
               <a:defRPr sz="1300"/>
             </a:pPr>
             <a:r>
-              <a:t>round 21 on LAPTOP-R77M5D6M - passed</a:t>
+              <a:t>round 22 on LAPTOP-R77M5D6M - passed</a:t>
             </a:r>
           </a:p>
           <a:p>

</xml_diff>